<commit_message>
Phase 8: historical run on Kaggle tweets (54.6k signals) + FinBERT vs VADER evaluation; compact data exports with automatic DB rebuild
- FinBERT 88.9% acc / 0.882 macro-F1 vs VADER 54.4% / 0.489 on 4,838 labelled sentences
- Historical backtest Sep 2021-Sep 2022: sentiment index -18.8% vs equal weight -19.2% vs S&P 500 -16.8%
- Fix tweet sampling for pandas 3 (groupby.apply dropped group columns)
- signals.db no longer committed; rebuilt from data/*.csv(.gz) exports on first use

Co-Authored-By: Claude Opus 5.5 <noreply@anthropic.com>
</commit_message>
<xml_diff>
--- a/docs/presentation.pptx
+++ b/docs/presentation.pptx
@@ -6265,7 +6265,7 @@
                           </a:solidFill>
                           <a:latin typeface="Segoe UI"/>
                         </a:rPr>
-                        <a:t>pending</a:t>
+                        <a:t>88.9%</a:t>
                       </a:r>
                     </a:p>
                   </a:txBody>
@@ -6288,7 +6288,7 @@
                           </a:solidFill>
                           <a:latin typeface="Segoe UI"/>
                         </a:rPr>
-                        <a:t>pending</a:t>
+                        <a:t>0.882</a:t>
                       </a:r>
                     </a:p>
                   </a:txBody>
@@ -6336,7 +6336,7 @@
                           </a:solidFill>
                           <a:latin typeface="Segoe UI"/>
                         </a:rPr>
-                        <a:t>pending</a:t>
+                        <a:t>54.4%</a:t>
                       </a:r>
                     </a:p>
                   </a:txBody>
@@ -6359,7 +6359,7 @@
                           </a:solidFill>
                           <a:latin typeface="Segoe UI"/>
                         </a:rPr>
-                        <a:t>pending</a:t>
+                        <a:t>0.489</a:t>
                       </a:r>
                     </a:p>
                   </a:txBody>
@@ -6382,8 +6382,8 @@
         </p:nvSpPr>
         <p:spPr>
           <a:xfrm>
-            <a:off x="548640" y="3657600"/>
-            <a:ext cx="5120640" cy="365760"/>
+            <a:off x="548640" y="3063240"/>
+            <a:ext cx="5120640" cy="274320"/>
           </a:xfrm>
           <a:prstGeom prst="rect">
             <a:avLst/>
@@ -6405,20 +6405,62 @@
               </a:spcAft>
             </a:pPr>
             <a:r>
-              <a:rPr sz="1500" b="1">
-                <a:solidFill>
-                  <a:srgbClr val="0B0B0B"/>
+              <a:rPr sz="1100" b="0">
+                <a:solidFill>
+                  <a:srgbClr val="898781"/>
                 </a:solidFill>
                 <a:latin typeface="Segoe UI"/>
               </a:rPr>
-              <a:t>Backtest (synthetic sample, Jul – Aug 2022)</a:t>
+              <a:t>n = 4,838 sentences (Kaggle / Financial PhraseBank)</a:t>
+            </a:r>
+          </a:p>
+        </p:txBody>
+      </p:sp>
+      <p:sp>
+        <p:nvSpPr>
+          <p:cNvPr id="10" name="TextBox 9"/>
+          <p:cNvSpPr txBox="1"/>
+          <p:nvPr/>
+        </p:nvSpPr>
+        <p:spPr>
+          <a:xfrm>
+            <a:off x="548640" y="3657600"/>
+            <a:ext cx="5120640" cy="365760"/>
+          </a:xfrm>
+          <a:prstGeom prst="rect">
+            <a:avLst/>
+          </a:prstGeom>
+          <a:noFill/>
+        </p:spPr>
+        <p:txBody>
+          <a:bodyPr wrap="square" lIns="0" rIns="0">
+            <a:spAutoFit/>
+          </a:bodyPr>
+          <a:lstStyle/>
+          <a:p>
+            <a:pPr algn="l">
+              <a:lnSpc>
+                <a:spcPct val="110000"/>
+              </a:lnSpc>
+              <a:spcAft>
+                <a:spcPts val="600"/>
+              </a:spcAft>
+            </a:pPr>
+            <a:r>
+              <a:rPr sz="1500" b="1">
+                <a:solidFill>
+                  <a:srgbClr val="0B0B0B"/>
+                </a:solidFill>
+                <a:latin typeface="Segoe UI"/>
+              </a:rPr>
+              <a:t>Backtest (Kaggle tweets, Sep 2021 – Sep 2022)</a:t>
             </a:r>
           </a:p>
         </p:txBody>
       </p:sp>
       <p:graphicFrame>
         <p:nvGraphicFramePr>
-          <p:cNvPr id="10" name="Table 9"/>
+          <p:cNvPr id="11" name="Table 10"/>
           <p:cNvGraphicFramePr>
             <a:graphicFrameLocks noGrp="1"/>
           </p:cNvGraphicFramePr>
@@ -6571,7 +6613,7 @@
                           </a:solidFill>
                           <a:latin typeface="Segoe UI"/>
                         </a:rPr>
-                        <a:t>8.0%</a:t>
+                        <a:t>-18.8%</a:t>
                       </a:r>
                     </a:p>
                   </a:txBody>
@@ -6594,7 +6636,7 @@
                           </a:solidFill>
                           <a:latin typeface="Segoe UI"/>
                         </a:rPr>
-                        <a:t>1.98</a:t>
+                        <a:t>-0.65</a:t>
                       </a:r>
                     </a:p>
                   </a:txBody>
@@ -6617,7 +6659,7 @@
                           </a:solidFill>
                           <a:latin typeface="Segoe UI"/>
                         </a:rPr>
-                        <a:t>-7.3%</a:t>
+                        <a:t>-29.6%</a:t>
                       </a:r>
                     </a:p>
                   </a:txBody>
@@ -6665,7 +6707,7 @@
                           </a:solidFill>
                           <a:latin typeface="Segoe UI"/>
                         </a:rPr>
-                        <a:t>7.8%</a:t>
+                        <a:t>-19.2%</a:t>
                       </a:r>
                     </a:p>
                   </a:txBody>
@@ -6688,7 +6730,7 @@
                           </a:solidFill>
                           <a:latin typeface="Segoe UI"/>
                         </a:rPr>
-                        <a:t>1.95</a:t>
+                        <a:t>-0.66</a:t>
                       </a:r>
                     </a:p>
                   </a:txBody>
@@ -6711,7 +6753,7 @@
                           </a:solidFill>
                           <a:latin typeface="Segoe UI"/>
                         </a:rPr>
-                        <a:t>-7.2%</a:t>
+                        <a:t>-29.6%</a:t>
                       </a:r>
                     </a:p>
                   </a:txBody>
@@ -6759,7 +6801,7 @@
                           </a:solidFill>
                           <a:latin typeface="Segoe UI"/>
                         </a:rPr>
-                        <a:t>5.4%</a:t>
+                        <a:t>-16.8%</a:t>
                       </a:r>
                     </a:p>
                   </a:txBody>
@@ -6782,7 +6824,7 @@
                           </a:solidFill>
                           <a:latin typeface="Segoe UI"/>
                         </a:rPr>
-                        <a:t>1.75</a:t>
+                        <a:t>-0.73</a:t>
                       </a:r>
                     </a:p>
                   </a:txBody>
@@ -6805,7 +6847,7 @@
                           </a:solidFill>
                           <a:latin typeface="Segoe UI"/>
                         </a:rPr>
-                        <a:t>-6.4%</a:t>
+                        <a:t>-25.2%</a:t>
                       </a:r>
                     </a:p>
                   </a:txBody>
@@ -6822,7 +6864,7 @@
       </p:graphicFrame>
       <p:sp>
         <p:nvSpPr>
-          <p:cNvPr id="11" name="TextBox 10"/>
+          <p:cNvPr id="12" name="TextBox 11"/>
           <p:cNvSpPr txBox="1"/>
           <p:nvPr/>
         </p:nvSpPr>
@@ -6857,14 +6899,14 @@
                 </a:solidFill>
                 <a:latin typeface="Segoe UI"/>
               </a:rPr>
-              <a:t>Avg daily turnover 5.1%; no transaction costs. Illustrative only.</a:t>
+              <a:t>Avg daily turnover 2.3%; no transaction costs. Illustrative only.</a:t>
             </a:r>
           </a:p>
         </p:txBody>
       </p:sp>
       <p:pic>
         <p:nvPicPr>
-          <p:cNvPr id="12" name="Picture 11" descr="backtest_cumulative_sample.png"/>
+          <p:cNvPr id="13" name="Picture 12" descr="backtest_cumulative_historical.png"/>
           <p:cNvPicPr>
             <a:picLocks noChangeAspect="1"/>
           </p:cNvPicPr>
@@ -6888,7 +6930,7 @@
       </p:pic>
       <p:pic>
         <p:nvPicPr>
-          <p:cNvPr id="13" name="Picture 12" descr="weights_stacked_sample.png"/>
+          <p:cNvPr id="14" name="Picture 13" descr="weights_stacked_historical.png"/>
           <p:cNvPicPr>
             <a:picLocks noChangeAspect="1"/>
           </p:cNvPicPr>

</xml_diff>